<commit_message>
the project is now using a new logo
</commit_message>
<xml_diff>
--- a/presentation/attachifykenya.pptx
+++ b/presentation/attachifykenya.pptx
@@ -281,7 +281,7 @@
           <a:p>
             <a:fld id="{4954C6E1-AF92-4FB7-A013-0B520EBC30AE}" type="datetimeFigureOut">
               <a:rPr lang="en-US"/>
-              <a:t>7/7/2026</a:t>
+              <a:t>7/10/2026</a:t>
             </a:fld>
             <a:endParaRPr/>
           </a:p>
@@ -446,7 +446,7 @@
           <a:p>
             <a:fld id="{95C10850-0874-4A61-99B4-D613C5E8D9EA}" type="datetimeFigureOut">
               <a:rPr lang="en-US"/>
-              <a:t>7/7/2026</a:t>
+              <a:t>7/8/2026</a:t>
             </a:fld>
             <a:endParaRPr/>
           </a:p>
@@ -1023,7 +1023,7 @@
             <a:fld id="{3B9B9059-F1D6-41D0-95CF-D21CAA096B3A}" type="datetimeFigureOut">
               <a:rPr lang="en-US" smtClean="0"/>
               <a:pPr/>
-              <a:t>7/7/2026</a:t>
+              <a:t>7/8/2026</a:t>
             </a:fld>
             <a:endParaRPr lang="en-US"/>
           </a:p>
@@ -1375,7 +1375,7 @@
             <a:fld id="{3B9B9059-F1D6-41D0-95CF-D21CAA096B3A}" type="datetimeFigureOut">
               <a:rPr lang="en-US" smtClean="0"/>
               <a:pPr/>
-              <a:t>7/7/2026</a:t>
+              <a:t>7/8/2026</a:t>
             </a:fld>
             <a:endParaRPr lang="en-US"/>
           </a:p>
@@ -1574,7 +1574,7 @@
           <a:p>
             <a:fld id="{3B9B9059-F1D6-41D0-95CF-D21CAA096B3A}" type="datetimeFigureOut">
               <a:rPr lang="en-US" smtClean="0"/>
-              <a:t>7/7/2026</a:t>
+              <a:t>7/8/2026</a:t>
             </a:fld>
             <a:endParaRPr lang="en-US"/>
           </a:p>
@@ -1782,7 +1782,7 @@
           <a:p>
             <a:fld id="{3B9B9059-F1D6-41D0-95CF-D21CAA096B3A}" type="datetimeFigureOut">
               <a:rPr lang="en-US" smtClean="0"/>
-              <a:t>7/7/2026</a:t>
+              <a:t>7/8/2026</a:t>
             </a:fld>
             <a:endParaRPr lang="en-US"/>
           </a:p>
@@ -1990,7 +1990,7 @@
           <a:p>
             <a:fld id="{3B9B9059-F1D6-41D0-95CF-D21CAA096B3A}" type="datetimeFigureOut">
               <a:rPr lang="en-US" smtClean="0"/>
-              <a:t>7/7/2026</a:t>
+              <a:t>7/8/2026</a:t>
             </a:fld>
             <a:endParaRPr lang="en-US"/>
           </a:p>
@@ -2253,7 +2253,7 @@
           <a:p>
             <a:fld id="{3B9B9059-F1D6-41D0-95CF-D21CAA096B3A}" type="datetimeFigureOut">
               <a:rPr lang="en-US" smtClean="0"/>
-              <a:t>7/7/2026</a:t>
+              <a:t>7/8/2026</a:t>
             </a:fld>
             <a:endParaRPr lang="en-US"/>
           </a:p>
@@ -2562,7 +2562,7 @@
           <a:p>
             <a:fld id="{3B9B9059-F1D6-41D0-95CF-D21CAA096B3A}" type="datetimeFigureOut">
               <a:rPr lang="en-US" smtClean="0"/>
-              <a:t>7/7/2026</a:t>
+              <a:t>7/8/2026</a:t>
             </a:fld>
             <a:endParaRPr lang="en-US"/>
           </a:p>
@@ -3029,7 +3029,7 @@
           <a:p>
             <a:fld id="{3B9B9059-F1D6-41D0-95CF-D21CAA096B3A}" type="datetimeFigureOut">
               <a:rPr lang="en-US" smtClean="0"/>
-              <a:t>7/7/2026</a:t>
+              <a:t>7/8/2026</a:t>
             </a:fld>
             <a:endParaRPr lang="en-US"/>
           </a:p>
@@ -3164,7 +3164,7 @@
           <a:p>
             <a:fld id="{3B9B9059-F1D6-41D0-95CF-D21CAA096B3A}" type="datetimeFigureOut">
               <a:rPr lang="en-US" smtClean="0"/>
-              <a:t>7/7/2026</a:t>
+              <a:t>7/8/2026</a:t>
             </a:fld>
             <a:endParaRPr lang="en-US"/>
           </a:p>
@@ -3272,7 +3272,7 @@
             <a:fld id="{3B9B9059-F1D6-41D0-95CF-D21CAA096B3A}" type="datetimeFigureOut">
               <a:rPr lang="en-US" smtClean="0"/>
               <a:pPr/>
-              <a:t>7/7/2026</a:t>
+              <a:t>7/8/2026</a:t>
             </a:fld>
             <a:endParaRPr lang="en-US"/>
           </a:p>
@@ -3622,7 +3622,7 @@
             <a:fld id="{3B9B9059-F1D6-41D0-95CF-D21CAA096B3A}" type="datetimeFigureOut">
               <a:rPr lang="en-US" smtClean="0"/>
               <a:pPr/>
-              <a:t>7/7/2026</a:t>
+              <a:t>7/8/2026</a:t>
             </a:fld>
             <a:endParaRPr lang="en-US"/>
           </a:p>
@@ -3958,7 +3958,7 @@
             <a:fld id="{3B9B9059-F1D6-41D0-95CF-D21CAA096B3A}" type="datetimeFigureOut">
               <a:rPr lang="en-US" smtClean="0"/>
               <a:pPr/>
-              <a:t>7/7/2026</a:t>
+              <a:t>7/8/2026</a:t>
             </a:fld>
             <a:endParaRPr lang="en-US"/>
           </a:p>
@@ -4209,7 +4209,7 @@
             <a:fld id="{3B9B9059-F1D6-41D0-95CF-D21CAA096B3A}" type="datetimeFigureOut">
               <a:rPr lang="en-US" smtClean="0"/>
               <a:pPr/>
-              <a:t>7/7/2026</a:t>
+              <a:t>7/8/2026</a:t>
             </a:fld>
             <a:endParaRPr lang="en-US"/>
           </a:p>
@@ -4695,7 +4695,7 @@
           <a:p>
             <a:r>
               <a:rPr lang="en-US" sz="1800" dirty="0"/>
-              <a:t>Date: 8</a:t>
+              <a:t>Date: 10</a:t>
             </a:r>
             <a:r>
               <a:rPr lang="en-US" sz="1800" baseline="30000" dirty="0"/>
@@ -6744,10 +6744,10 @@
       </p:sp>
       <p:pic>
         <p:nvPicPr>
-          <p:cNvPr id="8" name="Content Placeholder 7">
+          <p:cNvPr id="6" name="Content Placeholder 5">
             <a:extLst>
               <a:ext uri="{FF2B5EF4-FFF2-40B4-BE49-F238E27FC236}">
-                <a16:creationId xmlns:a16="http://schemas.microsoft.com/office/drawing/2014/main" id="{0C930E9E-591F-4587-E99B-1B0D60B83E54}"/>
+                <a16:creationId xmlns:a16="http://schemas.microsoft.com/office/drawing/2014/main" id="{15899F0A-A3A1-5DC7-2018-8D3E2D14B44C}"/>
               </a:ext>
             </a:extLst>
           </p:cNvPr>
@@ -6766,8 +6766,8 @@
         </p:blipFill>
         <p:spPr>
           <a:xfrm>
-            <a:off x="608012" y="2190654"/>
-            <a:ext cx="5105400" cy="4362545"/>
+            <a:off x="0" y="1728304"/>
+            <a:ext cx="4189412" cy="4394200"/>
           </a:xfrm>
           <a:prstGeom prst="rect">
             <a:avLst/>
@@ -6776,10 +6776,10 @@
       </p:pic>
       <p:pic>
         <p:nvPicPr>
-          <p:cNvPr id="14" name="Content Placeholder 13">
+          <p:cNvPr id="11" name="Content Placeholder 10">
             <a:extLst>
               <a:ext uri="{FF2B5EF4-FFF2-40B4-BE49-F238E27FC236}">
-                <a16:creationId xmlns:a16="http://schemas.microsoft.com/office/drawing/2014/main" id="{4B95671C-3B17-5101-E9BA-D4C2DEDDBDE5}"/>
+                <a16:creationId xmlns:a16="http://schemas.microsoft.com/office/drawing/2014/main" id="{76C506E1-24A5-A877-5DD8-D81F10B8E4DF}"/>
               </a:ext>
             </a:extLst>
           </p:cNvPr>
@@ -6798,8 +6798,38 @@
         </p:blipFill>
         <p:spPr>
           <a:xfrm>
-            <a:off x="6246812" y="2190654"/>
-            <a:ext cx="4495800" cy="4133946"/>
+            <a:off x="4418012" y="1728304"/>
+            <a:ext cx="3048000" cy="2996096"/>
+          </a:xfrm>
+          <a:prstGeom prst="rect">
+            <a:avLst/>
+          </a:prstGeom>
+        </p:spPr>
+      </p:pic>
+      <p:pic>
+        <p:nvPicPr>
+          <p:cNvPr id="13" name="Picture 12">
+            <a:extLst>
+              <a:ext uri="{FF2B5EF4-FFF2-40B4-BE49-F238E27FC236}">
+                <a16:creationId xmlns:a16="http://schemas.microsoft.com/office/drawing/2014/main" id="{C6F40D5A-F021-5A49-FA9C-804491D049D9}"/>
+              </a:ext>
+            </a:extLst>
+          </p:cNvPr>
+          <p:cNvPicPr>
+            <a:picLocks noChangeAspect="1"/>
+          </p:cNvPicPr>
+          <p:nvPr/>
+        </p:nvPicPr>
+        <p:blipFill>
+          <a:blip r:embed="rId4"/>
+          <a:stretch>
+            <a:fillRect/>
+          </a:stretch>
+        </p:blipFill>
+        <p:spPr>
+          <a:xfrm>
+            <a:off x="7694612" y="1701800"/>
+            <a:ext cx="3962400" cy="3784599"/>
           </a:xfrm>
           <a:prstGeom prst="rect">
             <a:avLst/>

</xml_diff>